<commit_message>
fix: retire slide 2 (contexte) de la présentation point de stage
https://claude.ai/code/session_01NCqR7npDyVB3MSiKZsdvwC
</commit_message>
<xml_diff>
--- a/Point_Stage_TDXd.pptx
+++ b/Point_Stage_TDXd.pptx
@@ -12,7 +12,6 @@
     <p:sldId id="260" r:id="rId11"/>
     <p:sldId id="261" r:id="rId12"/>
     <p:sldId id="262" r:id="rId13"/>
-    <p:sldId id="263" r:id="rId14"/>
   </p:sldIdLst>
   <p:sldSz cx="12188952" cy="6858000" type="screen4x3"/>
   <p:notesSz cx="6858000" cy="9144000"/>
@@ -3363,261 +3362,6 @@
     <p:bg>
       <p:bgPr>
         <a:solidFill>
-          <a:srgbClr val="F2F2F2"/>
-        </a:solidFill>
-        <a:effectLst/>
-      </p:bgPr>
-    </p:bg>
-    <p:spTree>
-      <p:nvGrpSpPr>
-        <p:cNvPr id="1" name=""/>
-        <p:cNvGrpSpPr/>
-        <p:nvPr/>
-      </p:nvGrpSpPr>
-      <p:grpSpPr/>
-      <p:sp>
-        <p:nvSpPr>
-          <p:cNvPr id="2" name="Rectangle 1"/>
-          <p:cNvSpPr/>
-          <p:nvPr/>
-        </p:nvSpPr>
-        <p:spPr>
-          <a:xfrm>
-            <a:off x="0" y="0"/>
-            <a:ext cx="12188952" cy="1005840"/>
-          </a:xfrm>
-          <a:prstGeom prst="rect">
-            <a:avLst/>
-          </a:prstGeom>
-          <a:solidFill>
-            <a:srgbClr val="1F3864"/>
-          </a:solidFill>
-          <a:ln>
-            <a:noFill/>
-          </a:ln>
-        </p:spPr>
-        <p:style>
-          <a:lnRef idx="1">
-            <a:schemeClr val="accent1"/>
-          </a:lnRef>
-          <a:fillRef idx="3">
-            <a:schemeClr val="accent1"/>
-          </a:fillRef>
-          <a:effectRef idx="2">
-            <a:schemeClr val="accent1"/>
-          </a:effectRef>
-          <a:fontRef idx="minor">
-            <a:schemeClr val="lt1"/>
-          </a:fontRef>
-        </p:style>
-        <p:txBody>
-          <a:bodyPr rtlCol="0" anchor="ctr"/>
-          <a:lstStyle/>
-          <a:p>
-            <a:pPr algn="ctr"/>
-          </a:p>
-        </p:txBody>
-      </p:sp>
-      <p:sp>
-        <p:nvSpPr>
-          <p:cNvPr id="3" name="Rectangle 2"/>
-          <p:cNvSpPr/>
-          <p:nvPr/>
-        </p:nvSpPr>
-        <p:spPr>
-          <a:xfrm>
-            <a:off x="0" y="941832"/>
-            <a:ext cx="12188952" cy="64008"/>
-          </a:xfrm>
-          <a:prstGeom prst="rect">
-            <a:avLst/>
-          </a:prstGeom>
-          <a:solidFill>
-            <a:srgbClr val="4A86C8"/>
-          </a:solidFill>
-          <a:ln>
-            <a:noFill/>
-          </a:ln>
-        </p:spPr>
-        <p:style>
-          <a:lnRef idx="1">
-            <a:schemeClr val="accent1"/>
-          </a:lnRef>
-          <a:fillRef idx="3">
-            <a:schemeClr val="accent1"/>
-          </a:fillRef>
-          <a:effectRef idx="2">
-            <a:schemeClr val="accent1"/>
-          </a:effectRef>
-          <a:fontRef idx="minor">
-            <a:schemeClr val="lt1"/>
-          </a:fontRef>
-        </p:style>
-        <p:txBody>
-          <a:bodyPr rtlCol="0" anchor="ctr"/>
-          <a:lstStyle/>
-          <a:p>
-            <a:pPr algn="ctr"/>
-          </a:p>
-        </p:txBody>
-      </p:sp>
-      <p:sp>
-        <p:nvSpPr>
-          <p:cNvPr id="4" name="TextBox 3"/>
-          <p:cNvSpPr txBox="1"/>
-          <p:nvPr/>
-        </p:nvSpPr>
-        <p:spPr>
-          <a:xfrm>
-            <a:off x="320040" y="109728"/>
-            <a:ext cx="11430000" cy="822960"/>
-          </a:xfrm>
-          <a:prstGeom prst="rect">
-            <a:avLst/>
-          </a:prstGeom>
-          <a:noFill/>
-        </p:spPr>
-        <p:txBody>
-          <a:bodyPr wrap="none">
-            <a:spAutoFit/>
-          </a:bodyPr>
-          <a:lstStyle/>
-          <a:p>
-            <a:pPr algn="l"/>
-            <a:r>
-              <a:rPr sz="2800" b="1">
-                <a:solidFill>
-                  <a:srgbClr val="FFFFFF"/>
-                </a:solidFill>
-                <a:latin typeface="Calibri"/>
-              </a:rPr>
-              <a:t>Contexte &amp; Objectif</a:t>
-            </a:r>
-          </a:p>
-        </p:txBody>
-      </p:sp>
-      <p:sp>
-        <p:nvSpPr>
-          <p:cNvPr id="5" name="TextBox 4"/>
-          <p:cNvSpPr txBox="1"/>
-          <p:nvPr/>
-        </p:nvSpPr>
-        <p:spPr>
-          <a:xfrm>
-            <a:off x="502920" y="1188720"/>
-            <a:ext cx="11155680" cy="5303520"/>
-          </a:xfrm>
-          <a:prstGeom prst="rect">
-            <a:avLst/>
-          </a:prstGeom>
-          <a:noFill/>
-        </p:spPr>
-        <p:txBody>
-          <a:bodyPr wrap="square">
-            <a:spAutoFit/>
-          </a:bodyPr>
-          <a:lstStyle/>
-          <a:p>
-            <a:pPr>
-              <a:spcBef>
-                <a:spcPts val="1000"/>
-              </a:spcBef>
-              <a:buChar char="▶"/>
-            </a:pPr>
-            <a:r>
-              <a:rPr sz="1900">
-                <a:solidFill>
-                  <a:srgbClr val="404040"/>
-                </a:solidFill>
-                <a:latin typeface="Calibri"/>
-              </a:rPr>
-              <a:t>T-DXd : ADC (DAR=8), topoisomérase I inhibiteur (DXd)</a:t>
-            </a:r>
-          </a:p>
-          <a:p>
-            <a:pPr>
-              <a:spcBef>
-                <a:spcPts val="1000"/>
-              </a:spcBef>
-              <a:buChar char="▶"/>
-            </a:pPr>
-            <a:r>
-              <a:rPr sz="1900">
-                <a:solidFill>
-                  <a:srgbClr val="404040"/>
-                </a:solidFill>
-                <a:latin typeface="Calibri"/>
-              </a:rPr>
-              <a:t>Indication : cancer du sein HER2+ (FDA approuvé)</a:t>
-            </a:r>
-          </a:p>
-          <a:p>
-            <a:pPr>
-              <a:spcBef>
-                <a:spcPts val="1000"/>
-              </a:spcBef>
-              <a:buChar char="▶"/>
-            </a:pPr>
-            <a:r>
-              <a:rPr sz="1900">
-                <a:solidFill>
-                  <a:srgbClr val="404040"/>
-                </a:solidFill>
-                <a:latin typeface="Calibri"/>
-              </a:rPr>
-              <a:t>Problématique : toxicité hématologique dose-limitante (neutropénie, thrombopénie)</a:t>
-            </a:r>
-          </a:p>
-          <a:p>
-            <a:pPr>
-              <a:spcBef>
-                <a:spcPts val="1000"/>
-              </a:spcBef>
-              <a:buChar char="▶"/>
-            </a:pPr>
-            <a:r>
-              <a:rPr sz="1900">
-                <a:solidFill>
-                  <a:srgbClr val="404040"/>
-                </a:solidFill>
-                <a:latin typeface="Calibri"/>
-              </a:rPr>
-              <a:t>Objectif : modèle PK/PD mécanistique RAT pour prédire les nadirs hématologiques</a:t>
-            </a:r>
-          </a:p>
-          <a:p>
-            <a:pPr>
-              <a:spcBef>
-                <a:spcPts val="1000"/>
-              </a:spcBef>
-              <a:buChar char="▶"/>
-            </a:pPr>
-            <a:r>
-              <a:rPr sz="1900">
-                <a:solidFill>
-                  <a:srgbClr val="404040"/>
-                </a:solidFill>
-                <a:latin typeface="Calibri"/>
-              </a:rPr>
-              <a:t>Base : modèle de Fornari 2019 (carboplatin/rat) → étendu à T-DXd</a:t>
-            </a:r>
-          </a:p>
-        </p:txBody>
-      </p:sp>
-    </p:spTree>
-  </p:cSld>
-  <p:clrMapOvr>
-    <a:masterClrMapping/>
-  </p:clrMapOvr>
-</p:sld>
-</file>
-
-<file path=ppt/slides/slide3.xml><?xml version="1.0" encoding="utf-8"?>
-<p:sld xmlns:a="http://schemas.openxmlformats.org/drawingml/2006/main" xmlns:p="http://schemas.openxmlformats.org/presentationml/2006/main" xmlns:r="http://schemas.openxmlformats.org/officeDocument/2006/relationships">
-  <p:cSld>
-    <p:bg>
-      <p:bgPr>
-        <a:solidFill>
           <a:srgbClr val="FFFFFF"/>
         </a:solidFill>
         <a:effectLst/>
@@ -4222,7 +3966,7 @@
 </p:sld>
 </file>
 
-<file path=ppt/slides/slide4.xml><?xml version="1.0" encoding="utf-8"?>
+<file path=ppt/slides/slide3.xml><?xml version="1.0" encoding="utf-8"?>
 <p:sld xmlns:a="http://schemas.openxmlformats.org/drawingml/2006/main" xmlns:p="http://schemas.openxmlformats.org/presentationml/2006/main" xmlns:r="http://schemas.openxmlformats.org/officeDocument/2006/relationships">
   <p:cSld>
     <p:bg>
@@ -4928,6 +4672,212 @@
 </p:sld>
 </file>
 
+<file path=ppt/slides/slide4.xml><?xml version="1.0" encoding="utf-8"?>
+<p:sld xmlns:a="http://schemas.openxmlformats.org/drawingml/2006/main" xmlns:p="http://schemas.openxmlformats.org/presentationml/2006/main" xmlns:r="http://schemas.openxmlformats.org/officeDocument/2006/relationships">
+  <p:cSld>
+    <p:bg>
+      <p:bgPr>
+        <a:solidFill>
+          <a:srgbClr val="FFFFFF"/>
+        </a:solidFill>
+        <a:effectLst/>
+      </p:bgPr>
+    </p:bg>
+    <p:spTree>
+      <p:nvGrpSpPr>
+        <p:cNvPr id="1" name=""/>
+        <p:cNvGrpSpPr/>
+        <p:nvPr/>
+      </p:nvGrpSpPr>
+      <p:grpSpPr/>
+      <p:sp>
+        <p:nvSpPr>
+          <p:cNvPr id="2" name="Rectangle 1"/>
+          <p:cNvSpPr/>
+          <p:nvPr/>
+        </p:nvSpPr>
+        <p:spPr>
+          <a:xfrm>
+            <a:off x="0" y="0"/>
+            <a:ext cx="12188952" cy="1005840"/>
+          </a:xfrm>
+          <a:prstGeom prst="rect">
+            <a:avLst/>
+          </a:prstGeom>
+          <a:solidFill>
+            <a:srgbClr val="1F3864"/>
+          </a:solidFill>
+          <a:ln>
+            <a:noFill/>
+          </a:ln>
+        </p:spPr>
+        <p:style>
+          <a:lnRef idx="1">
+            <a:schemeClr val="accent1"/>
+          </a:lnRef>
+          <a:fillRef idx="3">
+            <a:schemeClr val="accent1"/>
+          </a:fillRef>
+          <a:effectRef idx="2">
+            <a:schemeClr val="accent1"/>
+          </a:effectRef>
+          <a:fontRef idx="minor">
+            <a:schemeClr val="lt1"/>
+          </a:fontRef>
+        </p:style>
+        <p:txBody>
+          <a:bodyPr rtlCol="0" anchor="ctr"/>
+          <a:lstStyle/>
+          <a:p>
+            <a:pPr algn="ctr"/>
+          </a:p>
+        </p:txBody>
+      </p:sp>
+      <p:sp>
+        <p:nvSpPr>
+          <p:cNvPr id="3" name="Rectangle 2"/>
+          <p:cNvSpPr/>
+          <p:nvPr/>
+        </p:nvSpPr>
+        <p:spPr>
+          <a:xfrm>
+            <a:off x="0" y="941832"/>
+            <a:ext cx="12188952" cy="64008"/>
+          </a:xfrm>
+          <a:prstGeom prst="rect">
+            <a:avLst/>
+          </a:prstGeom>
+          <a:solidFill>
+            <a:srgbClr val="4A86C8"/>
+          </a:solidFill>
+          <a:ln>
+            <a:noFill/>
+          </a:ln>
+        </p:spPr>
+        <p:style>
+          <a:lnRef idx="1">
+            <a:schemeClr val="accent1"/>
+          </a:lnRef>
+          <a:fillRef idx="3">
+            <a:schemeClr val="accent1"/>
+          </a:fillRef>
+          <a:effectRef idx="2">
+            <a:schemeClr val="accent1"/>
+          </a:effectRef>
+          <a:fontRef idx="minor">
+            <a:schemeClr val="lt1"/>
+          </a:fontRef>
+        </p:style>
+        <p:txBody>
+          <a:bodyPr rtlCol="0" anchor="ctr"/>
+          <a:lstStyle/>
+          <a:p>
+            <a:pPr algn="ctr"/>
+          </a:p>
+        </p:txBody>
+      </p:sp>
+      <p:sp>
+        <p:nvSpPr>
+          <p:cNvPr id="4" name="TextBox 3"/>
+          <p:cNvSpPr txBox="1"/>
+          <p:nvPr/>
+        </p:nvSpPr>
+        <p:spPr>
+          <a:xfrm>
+            <a:off x="320040" y="109728"/>
+            <a:ext cx="11430000" cy="822960"/>
+          </a:xfrm>
+          <a:prstGeom prst="rect">
+            <a:avLst/>
+          </a:prstGeom>
+          <a:noFill/>
+        </p:spPr>
+        <p:txBody>
+          <a:bodyPr wrap="none">
+            <a:spAutoFit/>
+          </a:bodyPr>
+          <a:lstStyle/>
+          <a:p>
+            <a:pPr algn="l"/>
+            <a:r>
+              <a:rPr sz="2800" b="1">
+                <a:solidFill>
+                  <a:srgbClr val="FFFFFF"/>
+                </a:solidFill>
+                <a:latin typeface="Calibri"/>
+              </a:rPr>
+              <a:t>Résultats PK — T-DXd 5 mg/kg Q3W × 3 cycles (Rat)</a:t>
+            </a:r>
+          </a:p>
+        </p:txBody>
+      </p:sp>
+      <p:pic>
+        <p:nvPicPr>
+          <p:cNvPr id="5" name="Picture 4" descr="PK_5mgkg.png"/>
+          <p:cNvPicPr>
+            <a:picLocks noChangeAspect="1"/>
+          </p:cNvPicPr>
+          <p:nvPr/>
+        </p:nvPicPr>
+        <p:blipFill>
+          <a:blip r:embed="rId2"/>
+          <a:stretch>
+            <a:fillRect/>
+          </a:stretch>
+        </p:blipFill>
+        <p:spPr>
+          <a:xfrm>
+            <a:off x="365760" y="1143000"/>
+            <a:ext cx="11457432" cy="5074920"/>
+          </a:xfrm>
+          <a:prstGeom prst="rect">
+            <a:avLst/>
+          </a:prstGeom>
+        </p:spPr>
+      </p:pic>
+      <p:sp>
+        <p:nvSpPr>
+          <p:cNvPr id="6" name="TextBox 5"/>
+          <p:cNvSpPr txBox="1"/>
+          <p:nvPr/>
+        </p:nvSpPr>
+        <p:spPr>
+          <a:xfrm>
+            <a:off x="365760" y="6291072"/>
+            <a:ext cx="11457432" cy="411480"/>
+          </a:xfrm>
+          <a:prstGeom prst="rect">
+            <a:avLst/>
+          </a:prstGeom>
+          <a:noFill/>
+        </p:spPr>
+        <p:txBody>
+          <a:bodyPr wrap="square">
+            <a:spAutoFit/>
+          </a:bodyPr>
+          <a:lstStyle/>
+          <a:p>
+            <a:pPr algn="ctr"/>
+            <a:r>
+              <a:rPr sz="1300" b="0" i="1">
+                <a:solidFill>
+                  <a:srgbClr val="505050"/>
+                </a:solidFill>
+                <a:latin typeface="Calibri"/>
+              </a:rPr>
+              <a:t>ADC sérum  |  DXd intracellulaire  |  Damage ADN — Krel temps-dépendant (Yin 2020)</a:t>
+            </a:r>
+          </a:p>
+        </p:txBody>
+      </p:sp>
+    </p:spTree>
+  </p:cSld>
+  <p:clrMapOvr>
+    <a:masterClrMapping/>
+  </p:clrMapOvr>
+</p:sld>
+</file>
+
 <file path=ppt/slides/slide5.xml><?xml version="1.0" encoding="utf-8"?>
 <p:sld xmlns:a="http://schemas.openxmlformats.org/drawingml/2006/main" xmlns:p="http://schemas.openxmlformats.org/presentationml/2006/main" xmlns:r="http://schemas.openxmlformats.org/officeDocument/2006/relationships">
   <p:cSld>
@@ -5062,212 +5012,6 @@
                 </a:solidFill>
                 <a:latin typeface="Calibri"/>
               </a:rPr>
-              <a:t>Résultats PK — T-DXd 5 mg/kg Q3W × 3 cycles (Rat)</a:t>
-            </a:r>
-          </a:p>
-        </p:txBody>
-      </p:sp>
-      <p:pic>
-        <p:nvPicPr>
-          <p:cNvPr id="5" name="Picture 4" descr="PK_5mgkg.png"/>
-          <p:cNvPicPr>
-            <a:picLocks noChangeAspect="1"/>
-          </p:cNvPicPr>
-          <p:nvPr/>
-        </p:nvPicPr>
-        <p:blipFill>
-          <a:blip r:embed="rId2"/>
-          <a:stretch>
-            <a:fillRect/>
-          </a:stretch>
-        </p:blipFill>
-        <p:spPr>
-          <a:xfrm>
-            <a:off x="365760" y="1143000"/>
-            <a:ext cx="11457432" cy="5074920"/>
-          </a:xfrm>
-          <a:prstGeom prst="rect">
-            <a:avLst/>
-          </a:prstGeom>
-        </p:spPr>
-      </p:pic>
-      <p:sp>
-        <p:nvSpPr>
-          <p:cNvPr id="6" name="TextBox 5"/>
-          <p:cNvSpPr txBox="1"/>
-          <p:nvPr/>
-        </p:nvSpPr>
-        <p:spPr>
-          <a:xfrm>
-            <a:off x="365760" y="6291072"/>
-            <a:ext cx="11457432" cy="411480"/>
-          </a:xfrm>
-          <a:prstGeom prst="rect">
-            <a:avLst/>
-          </a:prstGeom>
-          <a:noFill/>
-        </p:spPr>
-        <p:txBody>
-          <a:bodyPr wrap="square">
-            <a:spAutoFit/>
-          </a:bodyPr>
-          <a:lstStyle/>
-          <a:p>
-            <a:pPr algn="ctr"/>
-            <a:r>
-              <a:rPr sz="1300" b="0" i="1">
-                <a:solidFill>
-                  <a:srgbClr val="505050"/>
-                </a:solidFill>
-                <a:latin typeface="Calibri"/>
-              </a:rPr>
-              <a:t>ADC sérum  |  DXd intracellulaire  |  Damage ADN — Krel temps-dépendant (Yin 2020)</a:t>
-            </a:r>
-          </a:p>
-        </p:txBody>
-      </p:sp>
-    </p:spTree>
-  </p:cSld>
-  <p:clrMapOvr>
-    <a:masterClrMapping/>
-  </p:clrMapOvr>
-</p:sld>
-</file>
-
-<file path=ppt/slides/slide6.xml><?xml version="1.0" encoding="utf-8"?>
-<p:sld xmlns:a="http://schemas.openxmlformats.org/drawingml/2006/main" xmlns:p="http://schemas.openxmlformats.org/presentationml/2006/main" xmlns:r="http://schemas.openxmlformats.org/officeDocument/2006/relationships">
-  <p:cSld>
-    <p:bg>
-      <p:bgPr>
-        <a:solidFill>
-          <a:srgbClr val="FFFFFF"/>
-        </a:solidFill>
-        <a:effectLst/>
-      </p:bgPr>
-    </p:bg>
-    <p:spTree>
-      <p:nvGrpSpPr>
-        <p:cNvPr id="1" name=""/>
-        <p:cNvGrpSpPr/>
-        <p:nvPr/>
-      </p:nvGrpSpPr>
-      <p:grpSpPr/>
-      <p:sp>
-        <p:nvSpPr>
-          <p:cNvPr id="2" name="Rectangle 1"/>
-          <p:cNvSpPr/>
-          <p:nvPr/>
-        </p:nvSpPr>
-        <p:spPr>
-          <a:xfrm>
-            <a:off x="0" y="0"/>
-            <a:ext cx="12188952" cy="1005840"/>
-          </a:xfrm>
-          <a:prstGeom prst="rect">
-            <a:avLst/>
-          </a:prstGeom>
-          <a:solidFill>
-            <a:srgbClr val="1F3864"/>
-          </a:solidFill>
-          <a:ln>
-            <a:noFill/>
-          </a:ln>
-        </p:spPr>
-        <p:style>
-          <a:lnRef idx="1">
-            <a:schemeClr val="accent1"/>
-          </a:lnRef>
-          <a:fillRef idx="3">
-            <a:schemeClr val="accent1"/>
-          </a:fillRef>
-          <a:effectRef idx="2">
-            <a:schemeClr val="accent1"/>
-          </a:effectRef>
-          <a:fontRef idx="minor">
-            <a:schemeClr val="lt1"/>
-          </a:fontRef>
-        </p:style>
-        <p:txBody>
-          <a:bodyPr rtlCol="0" anchor="ctr"/>
-          <a:lstStyle/>
-          <a:p>
-            <a:pPr algn="ctr"/>
-          </a:p>
-        </p:txBody>
-      </p:sp>
-      <p:sp>
-        <p:nvSpPr>
-          <p:cNvPr id="3" name="Rectangle 2"/>
-          <p:cNvSpPr/>
-          <p:nvPr/>
-        </p:nvSpPr>
-        <p:spPr>
-          <a:xfrm>
-            <a:off x="0" y="941832"/>
-            <a:ext cx="12188952" cy="64008"/>
-          </a:xfrm>
-          <a:prstGeom prst="rect">
-            <a:avLst/>
-          </a:prstGeom>
-          <a:solidFill>
-            <a:srgbClr val="4A86C8"/>
-          </a:solidFill>
-          <a:ln>
-            <a:noFill/>
-          </a:ln>
-        </p:spPr>
-        <p:style>
-          <a:lnRef idx="1">
-            <a:schemeClr val="accent1"/>
-          </a:lnRef>
-          <a:fillRef idx="3">
-            <a:schemeClr val="accent1"/>
-          </a:fillRef>
-          <a:effectRef idx="2">
-            <a:schemeClr val="accent1"/>
-          </a:effectRef>
-          <a:fontRef idx="minor">
-            <a:schemeClr val="lt1"/>
-          </a:fontRef>
-        </p:style>
-        <p:txBody>
-          <a:bodyPr rtlCol="0" anchor="ctr"/>
-          <a:lstStyle/>
-          <a:p>
-            <a:pPr algn="ctr"/>
-          </a:p>
-        </p:txBody>
-      </p:sp>
-      <p:sp>
-        <p:nvSpPr>
-          <p:cNvPr id="4" name="TextBox 3"/>
-          <p:cNvSpPr txBox="1"/>
-          <p:nvPr/>
-        </p:nvSpPr>
-        <p:spPr>
-          <a:xfrm>
-            <a:off x="320040" y="109728"/>
-            <a:ext cx="11430000" cy="822960"/>
-          </a:xfrm>
-          <a:prstGeom prst="rect">
-            <a:avLst/>
-          </a:prstGeom>
-          <a:noFill/>
-        </p:spPr>
-        <p:txBody>
-          <a:bodyPr wrap="none">
-            <a:spAutoFit/>
-          </a:bodyPr>
-          <a:lstStyle/>
-          <a:p>
-            <a:pPr algn="l"/>
-            <a:r>
-              <a:rPr sz="2800" b="1">
-                <a:solidFill>
-                  <a:srgbClr val="FFFFFF"/>
-                </a:solidFill>
-                <a:latin typeface="Calibri"/>
-              </a:rPr>
               <a:t>Résultats PD — Comparaison 5 mg/kg vs 10 mg/kg</a:t>
             </a:r>
           </a:p>
@@ -5434,7 +5178,7 @@
 </p:sld>
 </file>
 
-<file path=ppt/slides/slide7.xml><?xml version="1.0" encoding="utf-8"?>
+<file path=ppt/slides/slide6.xml><?xml version="1.0" encoding="utf-8"?>
 <p:sld xmlns:a="http://schemas.openxmlformats.org/drawingml/2006/main" xmlns:p="http://schemas.openxmlformats.org/presentationml/2006/main" xmlns:r="http://schemas.openxmlformats.org/officeDocument/2006/relationships">
   <p:cSld>
     <p:bg>
@@ -5689,7 +5433,7 @@
 </p:sld>
 </file>
 
-<file path=ppt/slides/slide8.xml><?xml version="1.0" encoding="utf-8"?>
+<file path=ppt/slides/slide7.xml><?xml version="1.0" encoding="utf-8"?>
 <p:sld xmlns:a="http://schemas.openxmlformats.org/drawingml/2006/main" xmlns:p="http://schemas.openxmlformats.org/presentationml/2006/main" xmlns:r="http://schemas.openxmlformats.org/officeDocument/2006/relationships">
   <p:cSld>
     <p:bg>

</xml_diff>